<commit_message>
Amelioration des slides8,10 et 11.
</commit_message>
<xml_diff>
--- a/reports/Soutenance_MUPASA_KALUNGA_M2_DataScience.pptx
+++ b/reports/Soutenance_MUPASA_KALUNGA_M2_DataScience.pptx
@@ -482,7 +482,7 @@
           <a:p>
             <a:r>
               <a:rPr lang="en-US" dirty="0"/>
-              <a:t>1 minute. Message : « nous n'avons pas commencé par PPO ; nous y sommes arrivés après avoir testé et justifié chaque étape ». Cette progression est un choix méthodologique délibéré : elle permet d'isoler l'apport de chaque mécanisme (approximation par réseau, replay, clipping) et de répondre à la question « pourquoi le Deep RL plutôt que les méthodes tabulaires ? » avec des mesures plutôt que des arguments théoriques.</a:t>
+              <a:t>1 minute. Message : « nous n'avons pas commencé par PPO ; nous y sommes arrivés après avoir testé et justifié chaque étape ». Cette progression est un choix méthodologique délibéré : elle permet d'isoler l'apport de chaque mécanisme (approximation par réseau, replay, clipping) et de répondre à la question « pourquoi le Deep RL plutôt que les méthodes tabulaires ? » avec des mesures plutôt que des arguments théoriques. Détails à donner à l'oral : (1) Tabulaire → Deep RL — l'espace d'état à 147 dimensions n'est pas discrétisable sans perte majeure d'information ; pour Q-Learning/SARSA nous avons dû le réduire à 6 features, soit 17 034 états effectifs. (2) DQN → PPO — instabilité off-policy en environnement fortement stochastique ; PPO borne ses mises à jour par clipping.</a:t>
             </a:r>
           </a:p>
         </p:txBody>
@@ -1613,7 +1613,7 @@
           <a:p>
             <a:r>
               <a:rPr lang="en-US" dirty="0"/>
-              <a:t>1 minute. Trois difficultés majeures, présentées avec leur résolution. La première — le signal de récompense non discriminant — a d'abord été un blocage complet de l'apprentissage tabulaire, avant de devenir la contribution la plus originale du mémoire. La deuxième illustre la limite fondamentale des méthodes tabulaires et justifie le passage au Deep RL. La troisième montre une lecture critique de nos propres agents : PPO n'est pas présenté comme une solution miracle, sa variabilité en surcharge est documentée et expliquée.</a:t>
+              <a:t>1 minute. Trois difficultés majeures, présentées avec leur résolution. La première — le signal de récompense non discriminant — a d'abord été un blocage complet de l'apprentissage tabulaire, avant de devenir la contribution la plus originale du mémoire. La deuxième illustre la limite fondamentale des méthodes tabulaires et justifie le passage au Deep RL. La troisième montre une lecture critique de nos propres agents : PPO n'est pas présenté comme une solution miracle, sa variabilité en surcharge est documentée et expliquée. Détails à donner à l'oral : (1) la récompense initiale à 3 termes produisait un ΔR inférieur à 6×10⁻⁴, le diagnostic empirique a conduit à l'ajout du terme w₄ = 0,3 qui multiplie le signal par 53 ; (2) l'extraction de 6 features décisionnelles a rendu l'état tabulable (17 034 états effectifs pour Q-Learning/SARSA) ; (3) l'analyse comportementale de PPO en high_load (93,3 % d'ATTENDRE) explique son écart-type élevé, d'où le choix de DQN comme alternative stable.</a:t>
             </a:r>
           </a:p>
         </p:txBody>
@@ -3118,7 +3118,7 @@
                 <a:ea typeface="Calibri" pitchFamily="34" charset="-122"/>
                 <a:cs typeface="Calibri" pitchFamily="34" charset="-120"/>
               </a:rPr>
-              <a:t>Présenté par : </a:t>
+              <a:t xml:space="preserve">Présenté par : </a:t>
             </a:r>
             <a:r>
               <a:rPr lang="en-US" sz="1400" b="1" dirty="0">
@@ -3168,7 +3168,7 @@
                 <a:ea typeface="Calibri" pitchFamily="34" charset="-122"/>
                 <a:cs typeface="Calibri" pitchFamily="34" charset="-120"/>
               </a:rPr>
-              <a:t>Sous la direction de : </a:t>
+              <a:t xml:space="preserve">Sous la direction de : </a:t>
             </a:r>
             <a:r>
               <a:rPr lang="en-US" sz="1400" b="1" dirty="0">
@@ -3836,7 +3836,7 @@
         <p:spPr>
           <a:xfrm>
             <a:off x="457200" y="3749040"/>
-            <a:ext cx="8229600" cy="1005840"/>
+            <a:ext cx="8229600" cy="694944"/>
           </a:xfrm>
           <a:prstGeom prst="roundRect">
             <a:avLst>
@@ -3909,7 +3909,7 @@
         <p:spPr>
           <a:xfrm>
             <a:off x="658368" y="4133088"/>
-            <a:ext cx="7863840" cy="566928"/>
+            <a:ext cx="7863840" cy="256032"/>
           </a:xfrm>
           <a:prstGeom prst="rect">
             <a:avLst/>
@@ -3933,7 +3933,7 @@
                 <a:ea typeface="Calibri" pitchFamily="34" charset="-122"/>
                 <a:cs typeface="Calibri" pitchFamily="34" charset="-120"/>
               </a:rPr>
-              <a:t>Diagnostic empirique : mesure de l'écart de récompense ΔR entre l'action ATTENDRE et la meilleure action productive, sur états représentatifs. La formulation initiale à 3 termes rendait le signal non discriminant ; l'ajout du terme de pénalité d'attente directe (w₄ = 0,3) a débloqué la convergence de Q-Learning et SARSA.</a:t>
+              <a:t>Diagnostic empirique de ΔR → l'ajout de w₄ = 0,3 débloque la convergence tabulaire.</a:t>
             </a:r>
             <a:endParaRPr lang="en-US" sz="1050" dirty="0"/>
           </a:p>
@@ -5117,7 +5117,7 @@
                 <a:ea typeface="Calibri" pitchFamily="34" charset="-122"/>
                 <a:cs typeface="Calibri" pitchFamily="34" charset="-120"/>
               </a:rPr>
-              <a:t>Tabulaire → Deep RL : l'espace d'état à 147 dimensions n'est pas discrétisable sans perte majeure d'information (réduction à 6 features → 17 034 états effectifs)</a:t>
+              <a:t>Tabulaire → Deep RL : 147 dimensions non discrétisables sans perte majeure</a:t>
             </a:r>
             <a:endParaRPr lang="en-US" sz="1050" dirty="0"/>
           </a:p>
@@ -5138,7 +5138,7 @@
                 <a:ea typeface="Calibri" pitchFamily="34" charset="-122"/>
                 <a:cs typeface="Calibri" pitchFamily="34" charset="-120"/>
               </a:rPr>
-              <a:t>DQN → PPO : instabilité off-policy en environnement fortement stochastique ; PPO borne ses mises à jour par clipping</a:t>
+              <a:t>DQN → PPO : le clipping stabilise l'apprentissage en environnement stochastique</a:t>
             </a:r>
             <a:endParaRPr lang="en-US" sz="1050" dirty="0"/>
           </a:p>
@@ -6596,7 +6596,7 @@
         </p:nvSpPr>
         <p:spPr>
           <a:xfrm>
-            <a:off x="457200" y="4343400"/>
+            <a:off x="510639" y="4640580"/>
             <a:ext cx="8229600" cy="502920"/>
           </a:xfrm>
           <a:prstGeom prst="rect">
@@ -7253,7 +7253,7 @@
                 <a:ea typeface="Calibri" pitchFamily="34" charset="-122"/>
                 <a:cs typeface="Calibri" pitchFamily="34" charset="-120"/>
               </a:rPr>
-              <a:t>Pourquoi PPO plutôt que DQN ?  </a:t>
+              <a:t xml:space="preserve">Pourquoi PPO plutôt que DQN ?  </a:t>
             </a:r>
             <a:r>
               <a:rPr lang="en-US" sz="1100" dirty="0">
@@ -10809,7 +10809,7 @@
                 <a:ea typeface="Calibri" pitchFamily="34" charset="-122"/>
                 <a:cs typeface="Calibri" pitchFamily="34" charset="-120"/>
               </a:rPr>
-              <a:t>Significativité : </a:t>
+              <a:t xml:space="preserve">Significativité : </a:t>
             </a:r>
             <a:r>
               <a:rPr lang="en-US" sz="1050" dirty="0">
@@ -12122,7 +12122,7 @@
         <p:spPr>
           <a:xfrm>
             <a:off x="457200" y="1325880"/>
-            <a:ext cx="4114800" cy="2377440"/>
+            <a:ext cx="4114800" cy="1130808"/>
           </a:xfrm>
           <a:prstGeom prst="roundRect">
             <a:avLst>
@@ -12147,56 +12147,71 @@
           </a:effectLst>
         </p:spPr>
       </p:sp>
-      <p:pic>
-        <p:nvPicPr>
-          <p:cNvPr id="5" name="Image 0" descr="learning_curves_nominal.png"/>
-          <p:cNvPicPr>
-            <a:picLocks noChangeAspect="1"/>
-          </p:cNvPicPr>
-          <p:nvPr/>
-        </p:nvPicPr>
-        <p:blipFill>
-          <a:blip r:embed="rId3"/>
-          <a:stretch>
-            <a:fillRect/>
-          </a:stretch>
-        </p:blipFill>
-        <p:spPr>
-          <a:xfrm>
-            <a:off x="548640" y="1536192"/>
-            <a:ext cx="3931920" cy="1965960"/>
-          </a:xfrm>
-          <a:prstGeom prst="rect">
-            <a:avLst/>
-          </a:prstGeom>
-        </p:spPr>
-      </p:pic>
-      <p:sp>
-        <p:nvSpPr>
-          <p:cNvPr id="6" name="Text 3"/>
-          <p:cNvSpPr/>
-          <p:nvPr/>
-        </p:nvSpPr>
-        <p:spPr>
-          <a:xfrm>
-            <a:off x="457200" y="3767328"/>
-            <a:ext cx="4114800" cy="685800"/>
-          </a:xfrm>
-          <a:prstGeom prst="rect">
-            <a:avLst/>
-          </a:prstGeom>
-          <a:noFill/>
-          <a:ln/>
-        </p:spPr>
-        <p:txBody>
-          <a:bodyPr wrap="square" lIns="0" tIns="0" rIns="0" bIns="0" rtlCol="0" anchor="ctr"/>
-          <a:lstStyle/>
-          <a:p>
-            <a:pPr marL="0" indent="0">
-              <a:buNone/>
-            </a:pPr>
-            <a:r>
-              <a:rPr lang="en-US" sz="1000" i="1" dirty="0">
+      <p:sp>
+        <p:nvSpPr>
+          <p:cNvPr id="5" name="Text 3"/>
+          <p:cNvSpPr/>
+          <p:nvPr/>
+        </p:nvSpPr>
+        <p:spPr>
+          <a:xfrm>
+            <a:off x="548640" y="1463040"/>
+            <a:ext cx="3931920" cy="475488"/>
+          </a:xfrm>
+          <a:prstGeom prst="rect">
+            <a:avLst/>
+          </a:prstGeom>
+          <a:noFill/>
+          <a:ln/>
+        </p:spPr>
+        <p:txBody>
+          <a:bodyPr wrap="square" lIns="0" tIns="0" rIns="0" bIns="0" rtlCol="0" anchor="ctr"/>
+          <a:lstStyle/>
+          <a:p>
+            <a:pPr marL="0" indent="0" algn="ctr">
+              <a:buNone/>
+            </a:pPr>
+            <a:r>
+              <a:rPr lang="en-US" sz="2800" b="1" dirty="0">
+                <a:solidFill>
+                  <a:srgbClr val="B4622D"/>
+                </a:solidFill>
+                <a:latin typeface="Cambria" pitchFamily="34" charset="0"/>
+                <a:ea typeface="Cambria" pitchFamily="34" charset="-122"/>
+                <a:cs typeface="Cambria" pitchFamily="34" charset="-120"/>
+              </a:rPr>
+              <a:t>0,999</a:t>
+            </a:r>
+            <a:endParaRPr lang="en-US" sz="2800" dirty="0"/>
+          </a:p>
+        </p:txBody>
+      </p:sp>
+      <p:sp>
+        <p:nvSpPr>
+          <p:cNvPr id="6" name="Text 4"/>
+          <p:cNvSpPr/>
+          <p:nvPr/>
+        </p:nvSpPr>
+        <p:spPr>
+          <a:xfrm>
+            <a:off x="548640" y="1965960"/>
+            <a:ext cx="3931920" cy="402336"/>
+          </a:xfrm>
+          <a:prstGeom prst="rect">
+            <a:avLst/>
+          </a:prstGeom>
+          <a:noFill/>
+          <a:ln/>
+        </p:spPr>
+        <p:txBody>
+          <a:bodyPr wrap="square" lIns="0" tIns="0" rIns="0" bIns="0" rtlCol="0" anchor="ctr"/>
+          <a:lstStyle/>
+          <a:p>
+            <a:pPr marL="0" indent="0" algn="ctr">
+              <a:buNone/>
+            </a:pPr>
+            <a:r>
+              <a:rPr lang="en-US" sz="1050" dirty="0">
                 <a:solidFill>
                   <a:srgbClr val="5A6672"/>
                 </a:solidFill>
@@ -12204,22 +12219,22 @@
                 <a:ea typeface="Calibri" pitchFamily="34" charset="-122"/>
                 <a:cs typeface="Calibri" pitchFamily="34" charset="-120"/>
               </a:rPr>
-              <a:t>Q-Learning : 155 → 175 (+12,5 %) sur 30 000 épisodes · SARSA plafonne à ≈ 145 (−17 %) — l'off-policy l'emporte empiriquement.</a:t>
-            </a:r>
-            <a:endParaRPr lang="en-US" sz="1000" dirty="0"/>
-          </a:p>
-        </p:txBody>
-      </p:sp>
-      <p:sp>
-        <p:nvSpPr>
-          <p:cNvPr id="7" name="Shape 4"/>
-          <p:cNvSpPr/>
-          <p:nvPr/>
-        </p:nvSpPr>
-        <p:spPr>
-          <a:xfrm>
-            <a:off x="4754880" y="1325880"/>
-            <a:ext cx="3931920" cy="2377440"/>
+              <a:t>explained_variance de PPO — convergence confirmée</a:t>
+            </a:r>
+            <a:endParaRPr lang="en-US" sz="1050" dirty="0"/>
+          </a:p>
+        </p:txBody>
+      </p:sp>
+      <p:sp>
+        <p:nvSpPr>
+          <p:cNvPr id="11" name="Shape 8"/>
+          <p:cNvSpPr/>
+          <p:nvPr/>
+        </p:nvSpPr>
+        <p:spPr>
+          <a:xfrm>
+            <a:off x="457200" y="2572512"/>
+            <a:ext cx="4114800" cy="1130808"/>
           </a:xfrm>
           <a:prstGeom prst="roundRect">
             <a:avLst>
@@ -12244,6 +12259,118 @@
           </a:effectLst>
         </p:spPr>
       </p:sp>
+      <p:sp>
+        <p:nvSpPr>
+          <p:cNvPr id="12" name="Text 9"/>
+          <p:cNvSpPr/>
+          <p:nvPr/>
+        </p:nvSpPr>
+        <p:spPr>
+          <a:xfrm>
+            <a:off x="548640" y="2709672"/>
+            <a:ext cx="3931920" cy="475488"/>
+          </a:xfrm>
+          <a:prstGeom prst="rect">
+            <a:avLst/>
+          </a:prstGeom>
+          <a:noFill/>
+          <a:ln/>
+        </p:spPr>
+        <p:txBody>
+          <a:bodyPr wrap="square" lIns="0" tIns="0" rIns="0" bIns="0" rtlCol="0" anchor="ctr"/>
+          <a:lstStyle/>
+          <a:p>
+            <a:pPr marL="0" indent="0" algn="ctr">
+              <a:buNone/>
+            </a:pPr>
+            <a:r>
+              <a:rPr lang="en-US" sz="2800" b="1" dirty="0">
+                <a:solidFill>
+                  <a:srgbClr val="B4622D"/>
+                </a:solidFill>
+                <a:latin typeface="Cambria" pitchFamily="34" charset="0"/>
+                <a:ea typeface="Cambria" pitchFamily="34" charset="-122"/>
+                <a:cs typeface="Cambria" pitchFamily="34" charset="-120"/>
+              </a:rPr>
+              <a:t>80,3 %</a:t>
+            </a:r>
+            <a:endParaRPr lang="en-US" sz="2800" dirty="0"/>
+          </a:p>
+        </p:txBody>
+      </p:sp>
+      <p:sp>
+        <p:nvSpPr>
+          <p:cNvPr id="13" name="Text 10"/>
+          <p:cNvSpPr/>
+          <p:nvPr/>
+        </p:nvSpPr>
+        <p:spPr>
+          <a:xfrm>
+            <a:off x="548640" y="3212592"/>
+            <a:ext cx="3931920" cy="402336"/>
+          </a:xfrm>
+          <a:prstGeom prst="rect">
+            <a:avLst/>
+          </a:prstGeom>
+          <a:noFill/>
+          <a:ln/>
+        </p:spPr>
+        <p:txBody>
+          <a:bodyPr wrap="square" lIns="0" tIns="0" rIns="0" bIns="0" rtlCol="0" anchor="ctr"/>
+          <a:lstStyle/>
+          <a:p>
+            <a:pPr marL="0" indent="0" algn="ctr">
+              <a:buNone/>
+            </a:pPr>
+            <a:r>
+              <a:rPr lang="en-US" sz="1050" dirty="0">
+                <a:solidFill>
+                  <a:srgbClr val="5A6672"/>
+                </a:solidFill>
+                <a:latin typeface="Calibri" pitchFamily="34" charset="0"/>
+                <a:ea typeface="Calibri" pitchFamily="34" charset="-122"/>
+                <a:cs typeface="Calibri" pitchFamily="34" charset="-120"/>
+              </a:rPr>
+              <a:t>des décisions de DQN concentrées sur 2 actions</a:t>
+            </a:r>
+            <a:endParaRPr lang="en-US" sz="1050" dirty="0"/>
+          </a:p>
+        </p:txBody>
+      </p:sp>
+      <p:sp>
+        <p:nvSpPr>
+          <p:cNvPr id="7" name="Shape 4"/>
+          <p:cNvSpPr/>
+          <p:nvPr/>
+        </p:nvSpPr>
+        <p:spPr>
+          <a:xfrm>
+            <a:off x="4754880" y="1325880"/>
+            <a:ext cx="3931920" cy="2377440"/>
+          </a:xfrm>
+          <a:prstGeom prst="roundRect">
+            <a:avLst>
+              <a:gd name="adj" fmla="val 2308"/>
+            </a:avLst>
+          </a:prstGeom>
+          <a:solidFill>
+            <a:srgbClr val="FFFFFF"/>
+          </a:solidFill>
+          <a:ln w="9525">
+            <a:solidFill>
+              <a:srgbClr val="E3E7EA"/>
+            </a:solidFill>
+            <a:prstDash val="solid"/>
+          </a:ln>
+          <a:effectLst>
+            <a:outerShdw blurRad="88900" dist="25400" dir="2700000" algn="bl" rotWithShape="0">
+              <a:srgbClr val="000000">
+                <a:alpha val="13000"/>
+              </a:srgbClr>
+            </a:outerShdw>
+          </a:effectLst>
+        </p:spPr>
+      </p:sp>
       <p:pic>
         <p:nvPicPr>
           <p:cNvPr id="8" name="Image 1" descr="action_distribution_nominal.png"/>
@@ -12301,7 +12428,7 @@
                 <a:ea typeface="Calibri" pitchFamily="34" charset="-122"/>
                 <a:cs typeface="Calibri" pitchFamily="34" charset="-120"/>
               </a:rPr>
-              <a:t>DQN concentre 80,3 % de ses choix sur 2 actions (ATTENDRE 44,7 % + P1→D1 35,6 %) ; PPO diversifie sur les 7 actions.</a:t>
+              <a:t>Distribution des actions (nominal) — PPO diversifie sur les 7 actions.</a:t>
             </a:r>
             <a:endParaRPr lang="en-US" sz="1000" dirty="0"/>
           </a:p>
@@ -12340,7 +12467,7 @@
                 <a:ea typeface="Calibri" pitchFamily="34" charset="-122"/>
                 <a:cs typeface="Calibri" pitchFamily="34" charset="-120"/>
               </a:rPr>
-              <a:t>Nous n'avons pas seulement mesuré les scores : nous avons analysé ce que font les agents. PPO : explained_variance = 0,999 — convergence confirmée.</a:t>
+              <a:t>Au-delà des scores : nous avons analysé ce que font les agents.</a:t>
             </a:r>
             <a:endParaRPr lang="en-US" sz="1150" dirty="0"/>
           </a:p>
@@ -13076,7 +13203,7 @@
         </p:nvGraphicFramePr>
         <p:xfrm>
           <a:off x="457200" y="1417320"/>
-          <a:ext cx="8229600" cy="914400"/>
+          <a:ext cx="8229600" cy="2267712"/>
         </p:xfrm>
         <a:graphic>
           <a:graphicData uri="http://schemas.openxmlformats.org/drawingml/2006/table">
@@ -14299,7 +14426,7 @@
                 <a:ea typeface="Calibri" pitchFamily="34" charset="-122"/>
                 <a:cs typeface="Calibri" pitchFamily="34" charset="-120"/>
               </a:rPr>
-              <a:t>H1 validée dans 2 scénarios sur 3, sur la productivité ET le carburant. </a:t>
+              <a:t xml:space="preserve">H1 validée dans 2 scénarios sur 3, sur la productivité ET le carburant. </a:t>
             </a:r>
             <a:r>
               <a:rPr lang="en-US" sz="1150" dirty="0">
@@ -14533,7 +14660,7 @@
                 <a:ea typeface="Calibri" pitchFamily="34" charset="-122"/>
                 <a:cs typeface="Calibri" pitchFamily="34" charset="-120"/>
               </a:rPr>
-              <a:t>La récompense initiale à 3 termes produisait ΔR &lt; 6×10⁻⁴ : aucun apprentissage tabulaire possible</a:t>
+              <a:t>ΔR &lt; 6×10⁻⁴ : signal non discriminant, apprentissage bloqué</a:t>
             </a:r>
             <a:endParaRPr lang="en-US" sz="980" dirty="0"/>
           </a:p>
@@ -14572,7 +14699,7 @@
                 <a:ea typeface="Calibri" pitchFamily="34" charset="-122"/>
                 <a:cs typeface="Calibri" pitchFamily="34" charset="-120"/>
               </a:rPr>
-              <a:t>Diagnostic empirique → ajout du terme w₄ = 0,3 (ΔR ×53) — devenu une contribution du mémoire</a:t>
+              <a:t>Ajout de w₄ = 0,3 → ΔR ×53 — contribution du mémoire</a:t>
             </a:r>
             <a:endParaRPr lang="en-US" sz="980" dirty="0"/>
           </a:p>
@@ -14684,7 +14811,7 @@
                 <a:ea typeface="Calibri" pitchFamily="34" charset="-122"/>
                 <a:cs typeface="Calibri" pitchFamily="34" charset="-120"/>
               </a:rPr>
-              <a:t>147 dimensions continues : impossible à discrétiser sans explosion combinatoire</a:t>
+              <a:t>147 dimensions continues : discrétisation impossible</a:t>
             </a:r>
             <a:endParaRPr lang="en-US" sz="980" dirty="0"/>
           </a:p>
@@ -14723,7 +14850,7 @@
                 <a:ea typeface="Calibri" pitchFamily="34" charset="-122"/>
                 <a:cs typeface="Calibri" pitchFamily="34" charset="-120"/>
               </a:rPr>
-              <a:t>Extraction de 6 features décisionnelles → 17 034 états effectifs pour Q-Learning / SARSA</a:t>
+              <a:t>6 features décisionnelles → 17 034 états effectifs</a:t>
             </a:r>
             <a:endParaRPr lang="en-US" sz="980" dirty="0"/>
           </a:p>
@@ -14835,7 +14962,7 @@
                 <a:ea typeface="Calibri" pitchFamily="34" charset="-122"/>
                 <a:cs typeface="Calibri" pitchFamily="34" charset="-120"/>
               </a:rPr>
-              <a:t>Écart-type élevé en high_load (± 350 t/h) : sensibilité aux initialisations</a:t>
+              <a:t>± 350 t/h en high_load : sensible aux initialisations</a:t>
             </a:r>
             <a:endParaRPr lang="en-US" sz="980" dirty="0"/>
           </a:p>
@@ -14874,7 +15001,7 @@
                 <a:ea typeface="Calibri" pitchFamily="34" charset="-122"/>
                 <a:cs typeface="Calibri" pitchFamily="34" charset="-120"/>
               </a:rPr>
-              <a:t>Analyse comportementale (93,3 % ATTENDRE) ; DQN retenu comme alternative stable (± 65 t/h)</a:t>
+              <a:t>DQN retenu comme alternative stable (± 65 t/h)</a:t>
             </a:r>
             <a:endParaRPr lang="en-US" sz="980" dirty="0"/>
           </a:p>
@@ -20605,49 +20732,6 @@
               <a:t>w₁ = 1,0 · w₂ = 0,1 · w₃ = 0,05 · w₄ = 0,3</a:t>
             </a:r>
             <a:endParaRPr lang="en-US" sz="1050" dirty="0"/>
-          </a:p>
-        </p:txBody>
-      </p:sp>
-      <p:sp>
-        <p:nvSpPr>
-          <p:cNvPr id="20" name="Text 18"/>
-          <p:cNvSpPr/>
-          <p:nvPr/>
-        </p:nvSpPr>
-        <p:spPr>
-          <a:xfrm>
-            <a:off x="457200" y="4700016"/>
-            <a:ext cx="8229600" cy="384048"/>
-          </a:xfrm>
-          <a:prstGeom prst="rect">
-            <a:avLst/>
-          </a:prstGeom>
-          <a:noFill/>
-          <a:ln/>
-        </p:spPr>
-        <p:txBody>
-          <a:bodyPr wrap="square" lIns="0" tIns="0" rIns="0" bIns="0" rtlCol="0" anchor="ctr"/>
-          <a:lstStyle/>
-          <a:p>
-            <a:pPr marL="0" indent="0">
-              <a:buNone/>
-            </a:pPr>
-            <a:r>
-              <a:rPr lang="en-US" sz="1150" i="1" dirty="0">
-                <a:solidFill>
-                  <a:schemeClr val="bg1"/>
-                </a:solidFill>
-                <a:latin typeface="Calibri" pitchFamily="34" charset="0"/>
-                <a:ea typeface="Calibri" pitchFamily="34" charset="-122"/>
-                <a:cs typeface="Calibri" pitchFamily="34" charset="-120"/>
-              </a:rPr>
-              <a:t>Pourquoi 147 dimensions ? 12 camions × positions one-hot (7 nœuds) + files des 3 pelles et 2 dumps + disponibilités + temps + distances = 147 features.</a:t>
-            </a:r>
-            <a:endParaRPr lang="en-US" sz="1150" dirty="0">
-              <a:solidFill>
-                <a:schemeClr val="bg1"/>
-              </a:solidFill>
-            </a:endParaRPr>
           </a:p>
         </p:txBody>
       </p:sp>

</xml_diff>

<commit_message>
Mis a jour de la presentation.
</commit_message>
<xml_diff>
--- a/reports/Soutenance_MUPASA_KALUNGA_M2_DataScience.pptx
+++ b/reports/Soutenance_MUPASA_KALUNGA_M2_DataScience.pptx
@@ -7242,6 +7242,9 @@
           <a:lstStyle/>
           <a:p>
             <a:pPr marL="0" indent="0">
+              <a:spcAft>
+                <a:spcPts val="400"/>
+              </a:spcAft>
               <a:buNone/>
             </a:pPr>
             <a:r>
@@ -7253,18 +7256,69 @@
                 <a:ea typeface="Calibri" pitchFamily="34" charset="-122"/>
                 <a:cs typeface="Calibri" pitchFamily="34" charset="-120"/>
               </a:rPr>
-              <a:t xml:space="preserve">Pourquoi PPO plutôt que DQN ?  </a:t>
-            </a:r>
+              <a:t>Pourquoi PPO plutôt que DQN ?</a:t>
+            </a:r>
+            <a:endParaRPr lang="en-US" sz="1100" dirty="0"/>
+          </a:p>
+          <a:p>
+            <a:pPr marL="0" indent="0">
+              <a:spcAft>
+                <a:spcPts val="200"/>
+              </a:spcAft>
+              <a:buNone/>
+            </a:pPr>
             <a:r>
               <a:rPr lang="en-US" sz="1100" dirty="0">
                 <a:solidFill>
+                  <a:srgbClr val="8C4A1F"/>
+                </a:solidFill>
+                <a:latin typeface="Calibri" pitchFamily="34" charset="0"/>
+                <a:ea typeface="Calibri" pitchFamily="34" charset="-122"/>
+                <a:cs typeface="Calibri" pitchFamily="34" charset="-120"/>
+              </a:rPr>
+              <a:t xml:space="preserve">•  </a:t>
+            </a:r>
+            <a:r>
+              <a:rPr lang="en-US" sz="1100" dirty="0">
+                <a:solidFill>
                   <a:srgbClr val="22303F"/>
                 </a:solidFill>
                 <a:latin typeface="Calibri" pitchFamily="34" charset="0"/>
                 <a:ea typeface="Calibri" pitchFamily="34" charset="-122"/>
                 <a:cs typeface="Calibri" pitchFamily="34" charset="-120"/>
               </a:rPr>
-              <a:t>On-policy : apprend sur ses propres interactions, sans replay buffer — plus adapté à un environnement fortement stochastique. Peu sensible aux hyperparamètres (défauts SB3 : lr = 3×10⁻⁴, γ = 0,99, batch 64). Convergence confirmée : explained_variance = 0,999.</a:t>
+              <a:t>On-policy, sans replay buffer — adapté à l’environnement fortement stochastique</a:t>
+            </a:r>
+            <a:endParaRPr lang="en-US" sz="1100" dirty="0"/>
+          </a:p>
+          <a:p>
+            <a:pPr marL="0" indent="0">
+              <a:spcAft>
+                <a:spcPts val="0"/>
+              </a:spcAft>
+              <a:buNone/>
+            </a:pPr>
+            <a:r>
+              <a:rPr lang="en-US" sz="1100" dirty="0">
+                <a:solidFill>
+                  <a:srgbClr val="8C4A1F"/>
+                </a:solidFill>
+                <a:latin typeface="Calibri" pitchFamily="34" charset="0"/>
+                <a:ea typeface="Calibri" pitchFamily="34" charset="-122"/>
+                <a:cs typeface="Calibri" pitchFamily="34" charset="-120"/>
+              </a:rPr>
+              <a:t xml:space="preserve">•  </a:t>
+            </a:r>
+            <a:r>
+              <a:rPr lang="en-US" sz="1100" dirty="0">
+                <a:solidFill>
+                  <a:srgbClr val="22303F"/>
+                </a:solidFill>
+                <a:latin typeface="Calibri" pitchFamily="34" charset="0"/>
+                <a:ea typeface="Calibri" pitchFamily="34" charset="-122"/>
+                <a:cs typeface="Calibri" pitchFamily="34" charset="-120"/>
+              </a:rPr>
+              <a:t>Convergence confirmée : explained_variance = 0,999</a:t>
             </a:r>
             <a:endParaRPr lang="en-US" sz="1100" dirty="0"/>
           </a:p>

</xml_diff>

<commit_message>
Changement de l'entete de la page 2 de l'introduction.
</commit_message>
<xml_diff>
--- a/reports/Soutenance_MUPASA_KALUNGA_M2_DataScience.pptx
+++ b/reports/Soutenance_MUPASA_KALUNGA_M2_DataScience.pptx
@@ -3118,7 +3118,7 @@
                 <a:ea typeface="Calibri" pitchFamily="34" charset="-122"/>
                 <a:cs typeface="Calibri" pitchFamily="34" charset="-120"/>
               </a:rPr>
-              <a:t xml:space="preserve">Présenté par : </a:t>
+              <a:t>Présenté par : </a:t>
             </a:r>
             <a:r>
               <a:rPr lang="en-US" sz="1400" b="1" dirty="0">
@@ -3168,7 +3168,7 @@
                 <a:ea typeface="Calibri" pitchFamily="34" charset="-122"/>
                 <a:cs typeface="Calibri" pitchFamily="34" charset="-120"/>
               </a:rPr>
-              <a:t xml:space="preserve">Sous la direction de : </a:t>
+              <a:t>Sous la direction de : </a:t>
             </a:r>
             <a:r>
               <a:rPr lang="en-US" sz="1400" b="1" dirty="0">
@@ -7276,7 +7276,29 @@
                 <a:ea typeface="Calibri" pitchFamily="34" charset="-122"/>
                 <a:cs typeface="Calibri" pitchFamily="34" charset="-120"/>
               </a:rPr>
-              <a:t xml:space="preserve">•  </a:t>
+              <a:t>•  </a:t>
+            </a:r>
+            <a:r>
+              <a:rPr lang="fr-CD" sz="1100" dirty="0">
+                <a:solidFill>
+                  <a:srgbClr val="22303F"/>
+                </a:solidFill>
+                <a:latin typeface="Calibri" pitchFamily="34" charset="0"/>
+                <a:ea typeface="Calibri" pitchFamily="34" charset="-122"/>
+                <a:cs typeface="Calibri" pitchFamily="34" charset="-120"/>
+              </a:rPr>
+              <a:t>Mécanisme de </a:t>
+            </a:r>
+            <a:r>
+              <a:rPr lang="fr-CD" sz="1100" dirty="0" err="1">
+                <a:solidFill>
+                  <a:srgbClr val="22303F"/>
+                </a:solidFill>
+                <a:latin typeface="Calibri" pitchFamily="34" charset="0"/>
+                <a:ea typeface="Calibri" pitchFamily="34" charset="-122"/>
+                <a:cs typeface="Calibri" pitchFamily="34" charset="-120"/>
+              </a:rPr>
+              <a:t>clipping</a:t>
             </a:r>
             <a:r>
               <a:rPr lang="en-US" sz="1100" dirty="0">
@@ -7287,7 +7309,51 @@
                 <a:ea typeface="Calibri" pitchFamily="34" charset="-122"/>
                 <a:cs typeface="Calibri" pitchFamily="34" charset="-120"/>
               </a:rPr>
-              <a:t>On-policy, sans replay buffer — adapté à l’environnement fortement stochastique</a:t>
+              <a:t>, </a:t>
+            </a:r>
+            <a:r>
+              <a:rPr lang="en-US" sz="1100" dirty="0" err="1">
+                <a:solidFill>
+                  <a:srgbClr val="22303F"/>
+                </a:solidFill>
+                <a:latin typeface="Calibri" pitchFamily="34" charset="0"/>
+                <a:ea typeface="Calibri" pitchFamily="34" charset="-122"/>
+                <a:cs typeface="Calibri" pitchFamily="34" charset="-120"/>
+              </a:rPr>
+              <a:t>interdisant</a:t>
+            </a:r>
+            <a:r>
+              <a:rPr lang="en-US" sz="1100" dirty="0">
+                <a:solidFill>
+                  <a:srgbClr val="22303F"/>
+                </a:solidFill>
+                <a:latin typeface="Calibri" pitchFamily="34" charset="0"/>
+                <a:ea typeface="Calibri" pitchFamily="34" charset="-122"/>
+                <a:cs typeface="Calibri" pitchFamily="34" charset="-120"/>
+              </a:rPr>
+              <a:t> des mises à jour trop </a:t>
+            </a:r>
+            <a:r>
+              <a:rPr lang="en-US" sz="1100" dirty="0" err="1">
+                <a:solidFill>
+                  <a:srgbClr val="22303F"/>
+                </a:solidFill>
+                <a:latin typeface="Calibri" pitchFamily="34" charset="0"/>
+                <a:ea typeface="Calibri" pitchFamily="34" charset="-122"/>
+                <a:cs typeface="Calibri" pitchFamily="34" charset="-120"/>
+              </a:rPr>
+              <a:t>brutales</a:t>
+            </a:r>
+            <a:r>
+              <a:rPr lang="en-US" sz="1100" dirty="0">
+                <a:solidFill>
+                  <a:srgbClr val="22303F"/>
+                </a:solidFill>
+                <a:latin typeface="Calibri" pitchFamily="34" charset="0"/>
+                <a:ea typeface="Calibri" pitchFamily="34" charset="-122"/>
+                <a:cs typeface="Calibri" pitchFamily="34" charset="-120"/>
+              </a:rPr>
+              <a:t> — adapté à l’environnement fortement stochastique</a:t>
             </a:r>
             <a:endParaRPr lang="en-US" sz="1100" dirty="0"/>
           </a:p>
@@ -7307,7 +7373,7 @@
                 <a:ea typeface="Calibri" pitchFamily="34" charset="-122"/>
                 <a:cs typeface="Calibri" pitchFamily="34" charset="-120"/>
               </a:rPr>
-              <a:t xml:space="preserve">•  </a:t>
+              <a:t>•  </a:t>
             </a:r>
             <a:r>
               <a:rPr lang="en-US" sz="1100" dirty="0">
@@ -10863,7 +10929,7 @@
                 <a:ea typeface="Calibri" pitchFamily="34" charset="-122"/>
                 <a:cs typeface="Calibri" pitchFamily="34" charset="-120"/>
               </a:rPr>
-              <a:t xml:space="preserve">Significativité : </a:t>
+              <a:t>Significativité : </a:t>
             </a:r>
             <a:r>
               <a:rPr lang="en-US" sz="1050" dirty="0">
@@ -12434,7 +12500,7 @@
           <p:nvPr/>
         </p:nvPicPr>
         <p:blipFill>
-          <a:blip r:embed="rId4"/>
+          <a:blip r:embed="rId3"/>
           <a:stretch>
             <a:fillRect/>
           </a:stretch>
@@ -14480,7 +14546,7 @@
                 <a:ea typeface="Calibri" pitchFamily="34" charset="-122"/>
                 <a:cs typeface="Calibri" pitchFamily="34" charset="-120"/>
               </a:rPr>
-              <a:t xml:space="preserve">H1 validée dans 2 scénarios sur 3, sur la productivité ET le carburant. </a:t>
+              <a:t>H1 validée dans 2 scénarios sur 3, sur la productivité ET le carburant. </a:t>
             </a:r>
             <a:r>
               <a:rPr lang="en-US" sz="1150" dirty="0">
@@ -15434,7 +15500,29 @@
                 <a:ea typeface="Calibri" pitchFamily="34" charset="-122"/>
                 <a:cs typeface="Calibri" pitchFamily="34" charset="-120"/>
               </a:rPr>
-              <a:t>Transfer learning · meta-learning · architectures à taille variable (attention, GNN)</a:t>
+              <a:t>Transfer learning · meta-learning · architectures à taille </a:t>
+            </a:r>
+            <a:r>
+              <a:rPr lang="en-US" sz="950" b="1">
+                <a:solidFill>
+                  <a:srgbClr val="8C4A1F"/>
+                </a:solidFill>
+                <a:latin typeface="Calibri" pitchFamily="34" charset="0"/>
+                <a:ea typeface="Calibri" pitchFamily="34" charset="-122"/>
+                <a:cs typeface="Calibri" pitchFamily="34" charset="-120"/>
+              </a:rPr>
+              <a:t>variable (GAT, </a:t>
+            </a:r>
+            <a:r>
+              <a:rPr lang="en-US" sz="950" b="1" dirty="0">
+                <a:solidFill>
+                  <a:srgbClr val="8C4A1F"/>
+                </a:solidFill>
+                <a:latin typeface="Calibri" pitchFamily="34" charset="0"/>
+                <a:ea typeface="Calibri" pitchFamily="34" charset="-122"/>
+                <a:cs typeface="Calibri" pitchFamily="34" charset="-120"/>
+              </a:rPr>
+              <a:t>GNN)</a:t>
             </a:r>
             <a:endParaRPr lang="en-US" sz="950" dirty="0"/>
           </a:p>

</xml_diff>